<commit_message>
Them anh luong hoat dong
</commit_message>
<xml_diff>
--- a/PPTX/LTM_NHOM3.pptx
+++ b/PPTX/LTM_NHOM3.pptx
@@ -5,7 +5,7 @@
     <p:sldMasterId id="2147483648" r:id="rId1"/>
   </p:sldMasterIdLst>
   <p:notesMasterIdLst>
-    <p:notesMasterId r:id="rId26"/>
+    <p:notesMasterId r:id="rId27"/>
   </p:notesMasterIdLst>
   <p:sldIdLst>
     <p:sldId id="256" r:id="rId2"/>
@@ -17,29 +17,37 @@
     <p:sldId id="291" r:id="rId8"/>
     <p:sldId id="295" r:id="rId9"/>
     <p:sldId id="297" r:id="rId10"/>
-    <p:sldId id="298" r:id="rId11"/>
-    <p:sldId id="299" r:id="rId12"/>
-    <p:sldId id="300" r:id="rId13"/>
-    <p:sldId id="301" r:id="rId14"/>
-    <p:sldId id="302" r:id="rId15"/>
-    <p:sldId id="303" r:id="rId16"/>
-    <p:sldId id="304" r:id="rId17"/>
-    <p:sldId id="305" r:id="rId18"/>
-    <p:sldId id="306" r:id="rId19"/>
-    <p:sldId id="307" r:id="rId20"/>
-    <p:sldId id="308" r:id="rId21"/>
-    <p:sldId id="309" r:id="rId22"/>
-    <p:sldId id="310" r:id="rId23"/>
-    <p:sldId id="311" r:id="rId24"/>
-    <p:sldId id="282" r:id="rId25"/>
+    <p:sldId id="312" r:id="rId11"/>
+    <p:sldId id="298" r:id="rId12"/>
+    <p:sldId id="299" r:id="rId13"/>
+    <p:sldId id="300" r:id="rId14"/>
+    <p:sldId id="301" r:id="rId15"/>
+    <p:sldId id="302" r:id="rId16"/>
+    <p:sldId id="303" r:id="rId17"/>
+    <p:sldId id="304" r:id="rId18"/>
+    <p:sldId id="305" r:id="rId19"/>
+    <p:sldId id="306" r:id="rId20"/>
+    <p:sldId id="307" r:id="rId21"/>
+    <p:sldId id="308" r:id="rId22"/>
+    <p:sldId id="309" r:id="rId23"/>
+    <p:sldId id="310" r:id="rId24"/>
+    <p:sldId id="311" r:id="rId25"/>
+    <p:sldId id="282" r:id="rId26"/>
   </p:sldIdLst>
   <p:sldSz cx="18288000" cy="10287000"/>
   <p:notesSz cx="6858000" cy="9144000"/>
   <p:embeddedFontLst>
     <p:embeddedFont>
+      <p:font typeface="Calibri" panose="020F0502020204030204" pitchFamily="34" charset="0"/>
+      <p:regular r:id="rId28"/>
+      <p:bold r:id="rId29"/>
+      <p:italic r:id="rId30"/>
+      <p:boldItalic r:id="rId31"/>
+    </p:embeddedFont>
+    <p:embeddedFont>
       <p:font typeface="Times New Roman Bold" panose="02020803070505020304" pitchFamily="18" charset="0"/>
-      <p:regular r:id="rId27"/>
-      <p:bold r:id="rId28"/>
+      <p:regular r:id="rId32"/>
+      <p:bold r:id="rId33"/>
     </p:embeddedFont>
   </p:embeddedFontLst>
   <p:defaultTextStyle>
@@ -250,7 +258,7 @@
           <a:p>
             <a:fld id="{A7F8DE3F-CD42-4DF0-A685-DF4B6D22454D}" type="datetimeFigureOut">
               <a:rPr lang="en-US" smtClean="0"/>
-              <a:t>4/13/2026</a:t>
+              <a:t>4/16/2026</a:t>
             </a:fld>
             <a:endParaRPr lang="en-US"/>
           </a:p>
@@ -697,7 +705,7 @@
             <a:fld id="{1D8BD707-D9CF-40AE-B4C6-C98DA3205C09}" type="datetimeFigureOut">
               <a:rPr lang="en-US" smtClean="0"/>
               <a:pPr/>
-              <a:t>4/13/2026</a:t>
+              <a:t>4/16/2026</a:t>
             </a:fld>
             <a:endParaRPr lang="en-US"/>
           </a:p>
@@ -862,7 +870,7 @@
             <a:fld id="{1D8BD707-D9CF-40AE-B4C6-C98DA3205C09}" type="datetimeFigureOut">
               <a:rPr lang="en-US" smtClean="0"/>
               <a:pPr/>
-              <a:t>4/13/2026</a:t>
+              <a:t>4/16/2026</a:t>
             </a:fld>
             <a:endParaRPr lang="en-US"/>
           </a:p>
@@ -1037,7 +1045,7 @@
             <a:fld id="{1D8BD707-D9CF-40AE-B4C6-C98DA3205C09}" type="datetimeFigureOut">
               <a:rPr lang="en-US" smtClean="0"/>
               <a:pPr/>
-              <a:t>4/13/2026</a:t>
+              <a:t>4/16/2026</a:t>
             </a:fld>
             <a:endParaRPr lang="en-US"/>
           </a:p>
@@ -1202,7 +1210,7 @@
             <a:fld id="{1D8BD707-D9CF-40AE-B4C6-C98DA3205C09}" type="datetimeFigureOut">
               <a:rPr lang="en-US" smtClean="0"/>
               <a:pPr/>
-              <a:t>4/13/2026</a:t>
+              <a:t>4/16/2026</a:t>
             </a:fld>
             <a:endParaRPr lang="en-US"/>
           </a:p>
@@ -1444,7 +1452,7 @@
             <a:fld id="{1D8BD707-D9CF-40AE-B4C6-C98DA3205C09}" type="datetimeFigureOut">
               <a:rPr lang="en-US" smtClean="0"/>
               <a:pPr/>
-              <a:t>4/13/2026</a:t>
+              <a:t>4/16/2026</a:t>
             </a:fld>
             <a:endParaRPr lang="en-US"/>
           </a:p>
@@ -1726,7 +1734,7 @@
             <a:fld id="{1D8BD707-D9CF-40AE-B4C6-C98DA3205C09}" type="datetimeFigureOut">
               <a:rPr lang="en-US" smtClean="0"/>
               <a:pPr/>
-              <a:t>4/13/2026</a:t>
+              <a:t>4/16/2026</a:t>
             </a:fld>
             <a:endParaRPr lang="en-US"/>
           </a:p>
@@ -2142,7 +2150,7 @@
             <a:fld id="{1D8BD707-D9CF-40AE-B4C6-C98DA3205C09}" type="datetimeFigureOut">
               <a:rPr lang="en-US" smtClean="0"/>
               <a:pPr/>
-              <a:t>4/13/2026</a:t>
+              <a:t>4/16/2026</a:t>
             </a:fld>
             <a:endParaRPr lang="en-US"/>
           </a:p>
@@ -2256,7 +2264,7 @@
             <a:fld id="{1D8BD707-D9CF-40AE-B4C6-C98DA3205C09}" type="datetimeFigureOut">
               <a:rPr lang="en-US" smtClean="0"/>
               <a:pPr/>
-              <a:t>4/13/2026</a:t>
+              <a:t>4/16/2026</a:t>
             </a:fld>
             <a:endParaRPr lang="en-US"/>
           </a:p>
@@ -2348,7 +2356,7 @@
             <a:fld id="{1D8BD707-D9CF-40AE-B4C6-C98DA3205C09}" type="datetimeFigureOut">
               <a:rPr lang="en-US" smtClean="0"/>
               <a:pPr/>
-              <a:t>4/13/2026</a:t>
+              <a:t>4/16/2026</a:t>
             </a:fld>
             <a:endParaRPr lang="en-US"/>
           </a:p>
@@ -2620,7 +2628,7 @@
             <a:fld id="{1D8BD707-D9CF-40AE-B4C6-C98DA3205C09}" type="datetimeFigureOut">
               <a:rPr lang="en-US" smtClean="0"/>
               <a:pPr/>
-              <a:t>4/13/2026</a:t>
+              <a:t>4/16/2026</a:t>
             </a:fld>
             <a:endParaRPr lang="en-US"/>
           </a:p>
@@ -2869,7 +2877,7 @@
             <a:fld id="{1D8BD707-D9CF-40AE-B4C6-C98DA3205C09}" type="datetimeFigureOut">
               <a:rPr lang="en-US" smtClean="0"/>
               <a:pPr/>
-              <a:t>4/13/2026</a:t>
+              <a:t>4/16/2026</a:t>
             </a:fld>
             <a:endParaRPr lang="en-US"/>
           </a:p>
@@ -3077,7 +3085,7 @@
             <a:fld id="{1D8BD707-D9CF-40AE-B4C6-C98DA3205C09}" type="datetimeFigureOut">
               <a:rPr lang="en-US" smtClean="0"/>
               <a:pPr/>
-              <a:t>4/13/2026</a:t>
+              <a:t>4/16/2026</a:t>
             </a:fld>
             <a:endParaRPr lang="en-US"/>
           </a:p>
@@ -3769,6 +3777,292 @@
         <p:cNvPr id="1" name="">
           <a:extLst>
             <a:ext uri="{FF2B5EF4-FFF2-40B4-BE49-F238E27FC236}">
+              <a16:creationId xmlns:a16="http://schemas.microsoft.com/office/drawing/2014/main" id="{5EEA883E-100C-6140-A9A3-C56B0818086B}"/>
+            </a:ext>
+          </a:extLst>
+        </p:cNvPr>
+        <p:cNvGrpSpPr/>
+        <p:nvPr/>
+      </p:nvGrpSpPr>
+      <p:grpSpPr>
+        <a:xfrm>
+          <a:off x="0" y="0"/>
+          <a:ext cx="0" cy="0"/>
+          <a:chOff x="0" y="0"/>
+          <a:chExt cx="0" cy="0"/>
+        </a:xfrm>
+      </p:grpSpPr>
+      <p:sp>
+        <p:nvSpPr>
+          <p:cNvPr id="2" name="Freeform 2">
+            <a:extLst>
+              <a:ext uri="{FF2B5EF4-FFF2-40B4-BE49-F238E27FC236}">
+                <a16:creationId xmlns:a16="http://schemas.microsoft.com/office/drawing/2014/main" id="{C9651C70-6C50-DFAE-E74C-1A130186DF98}"/>
+              </a:ext>
+            </a:extLst>
+          </p:cNvPr>
+          <p:cNvSpPr/>
+          <p:nvPr/>
+        </p:nvSpPr>
+        <p:spPr>
+          <a:xfrm>
+            <a:off x="-133548" y="0"/>
+            <a:ext cx="18288000" cy="10287000"/>
+          </a:xfrm>
+          <a:custGeom>
+            <a:avLst/>
+            <a:gdLst/>
+            <a:ahLst/>
+            <a:cxnLst/>
+            <a:rect l="l" t="t" r="r" b="b"/>
+            <a:pathLst>
+              <a:path w="18288000" h="10287000">
+                <a:moveTo>
+                  <a:pt x="0" y="0"/>
+                </a:moveTo>
+                <a:lnTo>
+                  <a:pt x="18288000" y="0"/>
+                </a:lnTo>
+                <a:lnTo>
+                  <a:pt x="18288000" y="10287000"/>
+                </a:lnTo>
+                <a:lnTo>
+                  <a:pt x="0" y="10287000"/>
+                </a:lnTo>
+                <a:lnTo>
+                  <a:pt x="0" y="0"/>
+                </a:lnTo>
+                <a:close/>
+              </a:path>
+            </a:pathLst>
+          </a:custGeom>
+          <a:blipFill>
+            <a:blip r:embed="rId2"/>
+            <a:stretch>
+              <a:fillRect/>
+            </a:stretch>
+          </a:blipFill>
+        </p:spPr>
+      </p:sp>
+      <p:sp>
+        <p:nvSpPr>
+          <p:cNvPr id="3" name="TextBox 3">
+            <a:extLst>
+              <a:ext uri="{FF2B5EF4-FFF2-40B4-BE49-F238E27FC236}">
+                <a16:creationId xmlns:a16="http://schemas.microsoft.com/office/drawing/2014/main" id="{55CED375-4E33-0EB3-D968-DB8134D06C35}"/>
+              </a:ext>
+            </a:extLst>
+          </p:cNvPr>
+          <p:cNvSpPr txBox="1"/>
+          <p:nvPr/>
+        </p:nvSpPr>
+        <p:spPr>
+          <a:xfrm>
+            <a:off x="533400" y="1485900"/>
+            <a:ext cx="12039600" cy="1450333"/>
+          </a:xfrm>
+          <a:prstGeom prst="rect">
+            <a:avLst/>
+          </a:prstGeom>
+        </p:spPr>
+        <p:txBody>
+          <a:bodyPr wrap="square" lIns="0" tIns="0" rIns="0" bIns="0" rtlCol="0" anchor="t">
+            <a:spAutoFit/>
+          </a:bodyPr>
+          <a:lstStyle/>
+          <a:p>
+            <a:pPr>
+              <a:lnSpc>
+                <a:spcPts val="5880"/>
+              </a:lnSpc>
+              <a:spcBef>
+                <a:spcPct val="0"/>
+              </a:spcBef>
+            </a:pPr>
+            <a:r>
+              <a:rPr lang="en-US" sz="4200" b="1" dirty="0">
+                <a:solidFill>
+                  <a:srgbClr val="000000"/>
+                </a:solidFill>
+                <a:latin typeface="Times New Roman Bold"/>
+                <a:ea typeface="Times New Roman Bold"/>
+                <a:cs typeface="Times New Roman Bold"/>
+                <a:sym typeface="Times New Roman Bold"/>
+              </a:rPr>
+              <a:t>3. PHÂN TÍCH VÀ THIẾT KẾ HỆ THỐNG:</a:t>
+            </a:r>
+          </a:p>
+          <a:p>
+            <a:pPr>
+              <a:lnSpc>
+                <a:spcPts val="5880"/>
+              </a:lnSpc>
+              <a:spcBef>
+                <a:spcPct val="0"/>
+              </a:spcBef>
+            </a:pPr>
+            <a:r>
+              <a:rPr lang="en-US" sz="4200" b="1" dirty="0">
+                <a:solidFill>
+                  <a:srgbClr val="000000"/>
+                </a:solidFill>
+                <a:latin typeface="Times New Roman Bold"/>
+                <a:ea typeface="Times New Roman Bold"/>
+                <a:cs typeface="Times New Roman Bold"/>
+                <a:sym typeface="Times New Roman Bold"/>
+              </a:rPr>
+              <a:t>3.2. </a:t>
+            </a:r>
+            <a:r>
+              <a:rPr lang="en-US" sz="4200" b="1" dirty="0" err="1">
+                <a:solidFill>
+                  <a:srgbClr val="000000"/>
+                </a:solidFill>
+                <a:latin typeface="Times New Roman Bold"/>
+                <a:ea typeface="Times New Roman Bold"/>
+                <a:cs typeface="Times New Roman Bold"/>
+                <a:sym typeface="Times New Roman Bold"/>
+              </a:rPr>
+              <a:t>Kiến</a:t>
+            </a:r>
+            <a:r>
+              <a:rPr lang="en-US" sz="4200" b="1" dirty="0">
+                <a:solidFill>
+                  <a:srgbClr val="000000"/>
+                </a:solidFill>
+                <a:latin typeface="Times New Roman Bold"/>
+                <a:ea typeface="Times New Roman Bold"/>
+                <a:cs typeface="Times New Roman Bold"/>
+                <a:sym typeface="Times New Roman Bold"/>
+              </a:rPr>
+              <a:t> </a:t>
+            </a:r>
+            <a:r>
+              <a:rPr lang="en-US" sz="4200" b="1" dirty="0" err="1">
+                <a:solidFill>
+                  <a:srgbClr val="000000"/>
+                </a:solidFill>
+                <a:latin typeface="Times New Roman Bold"/>
+                <a:ea typeface="Times New Roman Bold"/>
+                <a:cs typeface="Times New Roman Bold"/>
+                <a:sym typeface="Times New Roman Bold"/>
+              </a:rPr>
+              <a:t>trúc</a:t>
+            </a:r>
+            <a:r>
+              <a:rPr lang="en-US" sz="4200" b="1" dirty="0">
+                <a:solidFill>
+                  <a:srgbClr val="000000"/>
+                </a:solidFill>
+                <a:latin typeface="Times New Roman Bold"/>
+                <a:ea typeface="Times New Roman Bold"/>
+                <a:cs typeface="Times New Roman Bold"/>
+                <a:sym typeface="Times New Roman Bold"/>
+              </a:rPr>
+              <a:t> </a:t>
+            </a:r>
+            <a:r>
+              <a:rPr lang="en-US" sz="4200" b="1" dirty="0" err="1">
+                <a:solidFill>
+                  <a:srgbClr val="000000"/>
+                </a:solidFill>
+                <a:latin typeface="Times New Roman Bold"/>
+                <a:ea typeface="Times New Roman Bold"/>
+                <a:cs typeface="Times New Roman Bold"/>
+                <a:sym typeface="Times New Roman Bold"/>
+              </a:rPr>
+              <a:t>hệ</a:t>
+            </a:r>
+            <a:r>
+              <a:rPr lang="en-US" sz="4200" b="1" dirty="0">
+                <a:solidFill>
+                  <a:srgbClr val="000000"/>
+                </a:solidFill>
+                <a:latin typeface="Times New Roman Bold"/>
+                <a:ea typeface="Times New Roman Bold"/>
+                <a:cs typeface="Times New Roman Bold"/>
+                <a:sym typeface="Times New Roman Bold"/>
+              </a:rPr>
+              <a:t> </a:t>
+            </a:r>
+            <a:r>
+              <a:rPr lang="en-US" sz="4200" b="1" dirty="0" err="1">
+                <a:solidFill>
+                  <a:srgbClr val="000000"/>
+                </a:solidFill>
+                <a:latin typeface="Times New Roman Bold"/>
+                <a:ea typeface="Times New Roman Bold"/>
+                <a:cs typeface="Times New Roman Bold"/>
+                <a:sym typeface="Times New Roman Bold"/>
+              </a:rPr>
+              <a:t>thống</a:t>
+            </a:r>
+            <a:r>
+              <a:rPr lang="en-US" sz="4200" b="1" dirty="0">
+                <a:solidFill>
+                  <a:srgbClr val="000000"/>
+                </a:solidFill>
+                <a:latin typeface="Times New Roman Bold"/>
+                <a:ea typeface="Times New Roman Bold"/>
+                <a:cs typeface="Times New Roman Bold"/>
+                <a:sym typeface="Times New Roman Bold"/>
+              </a:rPr>
+              <a:t>:</a:t>
+            </a:r>
+          </a:p>
+        </p:txBody>
+      </p:sp>
+      <p:pic>
+        <p:nvPicPr>
+          <p:cNvPr id="6" name="Picture 5">
+            <a:extLst>
+              <a:ext uri="{FF2B5EF4-FFF2-40B4-BE49-F238E27FC236}">
+                <a16:creationId xmlns:a16="http://schemas.microsoft.com/office/drawing/2014/main" id="{668EE16E-071B-4EE4-8DDA-06A4CF65861D}"/>
+              </a:ext>
+            </a:extLst>
+          </p:cNvPr>
+          <p:cNvPicPr>
+            <a:picLocks noChangeAspect="1"/>
+          </p:cNvPicPr>
+          <p:nvPr/>
+        </p:nvPicPr>
+        <p:blipFill>
+          <a:blip r:embed="rId3"/>
+          <a:stretch>
+            <a:fillRect/>
+          </a:stretch>
+        </p:blipFill>
+        <p:spPr>
+          <a:xfrm>
+            <a:off x="6553200" y="2400300"/>
+            <a:ext cx="8752932" cy="7350767"/>
+          </a:xfrm>
+          <a:prstGeom prst="rect">
+            <a:avLst/>
+          </a:prstGeom>
+        </p:spPr>
+      </p:pic>
+    </p:spTree>
+    <p:extLst>
+      <p:ext uri="{BB962C8B-B14F-4D97-AF65-F5344CB8AC3E}">
+        <p14:creationId xmlns:p14="http://schemas.microsoft.com/office/powerpoint/2010/main" val="593397155"/>
+      </p:ext>
+    </p:extLst>
+  </p:cSld>
+  <p:clrMapOvr>
+    <a:masterClrMapping/>
+  </p:clrMapOvr>
+</p:sld>
+</file>
+
+<file path=ppt/slides/slide11.xml><?xml version="1.0" encoding="utf-8"?>
+<p:sld xmlns:a="http://schemas.openxmlformats.org/drawingml/2006/main" xmlns:r="http://schemas.openxmlformats.org/officeDocument/2006/relationships" xmlns:p="http://schemas.openxmlformats.org/presentationml/2006/main">
+  <p:cSld>
+    <p:spTree>
+      <p:nvGrpSpPr>
+        <p:cNvPr id="1" name="">
+          <a:extLst>
+            <a:ext uri="{FF2B5EF4-FFF2-40B4-BE49-F238E27FC236}">
               <a16:creationId xmlns:a16="http://schemas.microsoft.com/office/drawing/2014/main" id="{ABDADAF0-049C-10F2-FF38-F608ED407854}"/>
             </a:ext>
           </a:extLst>
@@ -4347,7 +4641,7 @@
 </p:sld>
 </file>
 
-<file path=ppt/slides/slide11.xml><?xml version="1.0" encoding="utf-8"?>
+<file path=ppt/slides/slide12.xml><?xml version="1.0" encoding="utf-8"?>
 <p:sld xmlns:a="http://schemas.openxmlformats.org/drawingml/2006/main" xmlns:r="http://schemas.openxmlformats.org/officeDocument/2006/relationships" xmlns:p="http://schemas.openxmlformats.org/presentationml/2006/main">
   <p:cSld>
     <p:spTree>
@@ -5045,7 +5339,7 @@
 </p:sld>
 </file>
 
-<file path=ppt/slides/slide12.xml><?xml version="1.0" encoding="utf-8"?>
+<file path=ppt/slides/slide13.xml><?xml version="1.0" encoding="utf-8"?>
 <p:sld xmlns:a="http://schemas.openxmlformats.org/drawingml/2006/main" xmlns:r="http://schemas.openxmlformats.org/officeDocument/2006/relationships" xmlns:p="http://schemas.openxmlformats.org/presentationml/2006/main">
   <p:cSld>
     <p:spTree>
@@ -5438,7 +5732,7 @@
 </p:sld>
 </file>
 
-<file path=ppt/slides/slide13.xml><?xml version="1.0" encoding="utf-8"?>
+<file path=ppt/slides/slide14.xml><?xml version="1.0" encoding="utf-8"?>
 <p:sld xmlns:a="http://schemas.openxmlformats.org/drawingml/2006/main" xmlns:r="http://schemas.openxmlformats.org/officeDocument/2006/relationships" xmlns:p="http://schemas.openxmlformats.org/presentationml/2006/main">
   <p:cSld>
     <p:spTree>
@@ -5858,7 +6152,7 @@
 </p:sld>
 </file>
 
-<file path=ppt/slides/slide14.xml><?xml version="1.0" encoding="utf-8"?>
+<file path=ppt/slides/slide15.xml><?xml version="1.0" encoding="utf-8"?>
 <p:sld xmlns:a="http://schemas.openxmlformats.org/drawingml/2006/main" xmlns:r="http://schemas.openxmlformats.org/officeDocument/2006/relationships" xmlns:p="http://schemas.openxmlformats.org/presentationml/2006/main">
   <p:cSld>
     <p:spTree>
@@ -6521,7 +6815,7 @@
 </p:sld>
 </file>
 
-<file path=ppt/slides/slide15.xml><?xml version="1.0" encoding="utf-8"?>
+<file path=ppt/slides/slide16.xml><?xml version="1.0" encoding="utf-8"?>
 <p:sld xmlns:a="http://schemas.openxmlformats.org/drawingml/2006/main" xmlns:r="http://schemas.openxmlformats.org/officeDocument/2006/relationships" xmlns:p="http://schemas.openxmlformats.org/presentationml/2006/main">
   <p:cSld>
     <p:spTree>
@@ -7079,7 +7373,7 @@
 </p:sld>
 </file>
 
-<file path=ppt/slides/slide16.xml><?xml version="1.0" encoding="utf-8"?>
+<file path=ppt/slides/slide17.xml><?xml version="1.0" encoding="utf-8"?>
 <p:sld xmlns:a="http://schemas.openxmlformats.org/drawingml/2006/main" xmlns:r="http://schemas.openxmlformats.org/officeDocument/2006/relationships" xmlns:p="http://schemas.openxmlformats.org/presentationml/2006/main">
   <p:cSld>
     <p:spTree>
@@ -7732,7 +8026,7 @@
 </p:sld>
 </file>
 
-<file path=ppt/slides/slide17.xml><?xml version="1.0" encoding="utf-8"?>
+<file path=ppt/slides/slide18.xml><?xml version="1.0" encoding="utf-8"?>
 <p:sld xmlns:a="http://schemas.openxmlformats.org/drawingml/2006/main" xmlns:r="http://schemas.openxmlformats.org/officeDocument/2006/relationships" xmlns:p="http://schemas.openxmlformats.org/presentationml/2006/main">
   <p:cSld>
     <p:spTree>
@@ -8177,7 +8471,7 @@
 </p:sld>
 </file>
 
-<file path=ppt/slides/slide18.xml><?xml version="1.0" encoding="utf-8"?>
+<file path=ppt/slides/slide19.xml><?xml version="1.0" encoding="utf-8"?>
 <p:sld xmlns:a="http://schemas.openxmlformats.org/drawingml/2006/main" xmlns:r="http://schemas.openxmlformats.org/officeDocument/2006/relationships" xmlns:p="http://schemas.openxmlformats.org/presentationml/2006/main">
   <p:cSld>
     <p:spTree>
@@ -8724,7 +9018,824 @@
 </p:sld>
 </file>
 
-<file path=ppt/slides/slide19.xml><?xml version="1.0" encoding="utf-8"?>
+<file path=ppt/slides/slide2.xml><?xml version="1.0" encoding="utf-8"?>
+<p:sld xmlns:a="http://schemas.openxmlformats.org/drawingml/2006/main" xmlns:r="http://schemas.openxmlformats.org/officeDocument/2006/relationships" xmlns:p="http://schemas.openxmlformats.org/presentationml/2006/main">
+  <p:cSld>
+    <p:spTree>
+      <p:nvGrpSpPr>
+        <p:cNvPr id="1" name=""/>
+        <p:cNvGrpSpPr/>
+        <p:nvPr/>
+      </p:nvGrpSpPr>
+      <p:grpSpPr>
+        <a:xfrm>
+          <a:off x="0" y="0"/>
+          <a:ext cx="0" cy="0"/>
+          <a:chOff x="0" y="0"/>
+          <a:chExt cx="0" cy="0"/>
+        </a:xfrm>
+      </p:grpSpPr>
+      <p:sp>
+        <p:nvSpPr>
+          <p:cNvPr id="2" name="Freeform 2"/>
+          <p:cNvSpPr/>
+          <p:nvPr/>
+        </p:nvSpPr>
+        <p:spPr>
+          <a:xfrm>
+            <a:off x="-32657" y="-128736"/>
+            <a:ext cx="18288000" cy="10287000"/>
+          </a:xfrm>
+          <a:custGeom>
+            <a:avLst/>
+            <a:gdLst/>
+            <a:ahLst/>
+            <a:cxnLst/>
+            <a:rect l="l" t="t" r="r" b="b"/>
+            <a:pathLst>
+              <a:path w="18288000" h="10287000">
+                <a:moveTo>
+                  <a:pt x="0" y="0"/>
+                </a:moveTo>
+                <a:lnTo>
+                  <a:pt x="18288000" y="0"/>
+                </a:lnTo>
+                <a:lnTo>
+                  <a:pt x="18288000" y="10287000"/>
+                </a:lnTo>
+                <a:lnTo>
+                  <a:pt x="0" y="10287000"/>
+                </a:lnTo>
+                <a:lnTo>
+                  <a:pt x="0" y="0"/>
+                </a:lnTo>
+                <a:close/>
+              </a:path>
+            </a:pathLst>
+          </a:custGeom>
+          <a:blipFill>
+            <a:blip r:embed="rId2"/>
+            <a:stretch>
+              <a:fillRect/>
+            </a:stretch>
+          </a:blipFill>
+        </p:spPr>
+        <p:txBody>
+          <a:bodyPr/>
+          <a:lstStyle/>
+          <a:p>
+            <a:endParaRPr lang="en-US" dirty="0"/>
+          </a:p>
+        </p:txBody>
+      </p:sp>
+      <p:sp>
+        <p:nvSpPr>
+          <p:cNvPr id="6" name="TextBox 6"/>
+          <p:cNvSpPr txBox="1"/>
+          <p:nvPr/>
+        </p:nvSpPr>
+        <p:spPr>
+          <a:xfrm>
+            <a:off x="1600200" y="4229100"/>
+            <a:ext cx="4886157" cy="4802981"/>
+          </a:xfrm>
+          <a:prstGeom prst="rect">
+            <a:avLst/>
+          </a:prstGeom>
+        </p:spPr>
+        <p:txBody>
+          <a:bodyPr wrap="square" lIns="0" tIns="0" rIns="0" bIns="0" rtlCol="0" anchor="t">
+            <a:spAutoFit/>
+          </a:bodyPr>
+          <a:lstStyle/>
+          <a:p>
+            <a:pPr algn="ctr">
+              <a:lnSpc>
+                <a:spcPts val="4200"/>
+              </a:lnSpc>
+              <a:spcBef>
+                <a:spcPct val="0"/>
+              </a:spcBef>
+            </a:pPr>
+            <a:r>
+              <a:rPr lang="en-US" sz="3000" dirty="0">
+                <a:solidFill>
+                  <a:srgbClr val="000000"/>
+                </a:solidFill>
+                <a:latin typeface="Times New Roman"/>
+                <a:ea typeface="Times New Roman"/>
+                <a:cs typeface="Times New Roman"/>
+                <a:sym typeface="Times New Roman"/>
+              </a:rPr>
+              <a:t>1. Trịnh Văn </a:t>
+            </a:r>
+            <a:r>
+              <a:rPr lang="en-US" sz="3000" dirty="0" err="1">
+                <a:solidFill>
+                  <a:srgbClr val="000000"/>
+                </a:solidFill>
+                <a:latin typeface="Times New Roman"/>
+                <a:ea typeface="Times New Roman"/>
+                <a:cs typeface="Times New Roman"/>
+                <a:sym typeface="Times New Roman"/>
+              </a:rPr>
+              <a:t>Thưởng</a:t>
+            </a:r>
+            <a:r>
+              <a:rPr lang="en-US" sz="3000" dirty="0">
+                <a:solidFill>
+                  <a:srgbClr val="000000"/>
+                </a:solidFill>
+                <a:latin typeface="Times New Roman"/>
+                <a:ea typeface="Times New Roman"/>
+                <a:cs typeface="Times New Roman"/>
+                <a:sym typeface="Times New Roman"/>
+              </a:rPr>
+              <a:t> 2251150081</a:t>
+            </a:r>
+          </a:p>
+          <a:p>
+            <a:pPr algn="ctr">
+              <a:lnSpc>
+                <a:spcPts val="4200"/>
+              </a:lnSpc>
+              <a:spcBef>
+                <a:spcPct val="0"/>
+              </a:spcBef>
+            </a:pPr>
+            <a:endParaRPr lang="en-US" sz="3000" dirty="0">
+              <a:solidFill>
+                <a:srgbClr val="000000"/>
+              </a:solidFill>
+              <a:latin typeface="Times New Roman"/>
+              <a:ea typeface="Times New Roman"/>
+              <a:cs typeface="Times New Roman"/>
+              <a:sym typeface="Times New Roman"/>
+            </a:endParaRPr>
+          </a:p>
+          <a:p>
+            <a:pPr algn="ctr">
+              <a:lnSpc>
+                <a:spcPts val="4200"/>
+              </a:lnSpc>
+              <a:spcBef>
+                <a:spcPct val="0"/>
+              </a:spcBef>
+            </a:pPr>
+            <a:endParaRPr lang="en-US" sz="3000" dirty="0">
+              <a:solidFill>
+                <a:srgbClr val="000000"/>
+              </a:solidFill>
+              <a:latin typeface="Times New Roman"/>
+              <a:ea typeface="Times New Roman"/>
+              <a:cs typeface="Times New Roman"/>
+              <a:sym typeface="Times New Roman"/>
+            </a:endParaRPr>
+          </a:p>
+          <a:p>
+            <a:pPr algn="ctr">
+              <a:lnSpc>
+                <a:spcPts val="4200"/>
+              </a:lnSpc>
+              <a:spcBef>
+                <a:spcPct val="0"/>
+              </a:spcBef>
+            </a:pPr>
+            <a:endParaRPr lang="en-US" sz="3000" dirty="0">
+              <a:solidFill>
+                <a:srgbClr val="000000"/>
+              </a:solidFill>
+              <a:latin typeface="Times New Roman"/>
+              <a:ea typeface="Times New Roman"/>
+              <a:cs typeface="Times New Roman"/>
+              <a:sym typeface="Times New Roman"/>
+            </a:endParaRPr>
+          </a:p>
+          <a:p>
+            <a:pPr algn="ctr">
+              <a:lnSpc>
+                <a:spcPts val="4200"/>
+              </a:lnSpc>
+              <a:spcBef>
+                <a:spcPct val="0"/>
+              </a:spcBef>
+            </a:pPr>
+            <a:endParaRPr lang="en-US" sz="3000" dirty="0">
+              <a:solidFill>
+                <a:srgbClr val="000000"/>
+              </a:solidFill>
+              <a:latin typeface="Times New Roman"/>
+              <a:ea typeface="Times New Roman"/>
+              <a:cs typeface="Times New Roman"/>
+              <a:sym typeface="Times New Roman"/>
+            </a:endParaRPr>
+          </a:p>
+          <a:p>
+            <a:pPr algn="ctr">
+              <a:lnSpc>
+                <a:spcPts val="4200"/>
+              </a:lnSpc>
+              <a:spcBef>
+                <a:spcPct val="0"/>
+              </a:spcBef>
+            </a:pPr>
+            <a:r>
+              <a:rPr lang="en-US" sz="3000" dirty="0">
+                <a:solidFill>
+                  <a:srgbClr val="000000"/>
+                </a:solidFill>
+                <a:latin typeface="Times New Roman"/>
+                <a:ea typeface="Times New Roman"/>
+                <a:cs typeface="Times New Roman"/>
+                <a:sym typeface="Times New Roman"/>
+              </a:rPr>
+              <a:t>2. Nguyễn Thành Đạt</a:t>
+            </a:r>
+          </a:p>
+          <a:p>
+            <a:pPr algn="ctr">
+              <a:lnSpc>
+                <a:spcPts val="4200"/>
+              </a:lnSpc>
+              <a:spcBef>
+                <a:spcPct val="0"/>
+              </a:spcBef>
+            </a:pPr>
+            <a:r>
+              <a:rPr lang="en-US" sz="3000" dirty="0">
+                <a:solidFill>
+                  <a:srgbClr val="000000"/>
+                </a:solidFill>
+                <a:latin typeface="Times New Roman"/>
+                <a:ea typeface="Times New Roman"/>
+                <a:cs typeface="Times New Roman"/>
+                <a:sym typeface="Times New Roman"/>
+              </a:rPr>
+              <a:t>058206008394</a:t>
+            </a:r>
+          </a:p>
+          <a:p>
+            <a:pPr marL="514350" indent="-514350" algn="ctr">
+              <a:lnSpc>
+                <a:spcPts val="4200"/>
+              </a:lnSpc>
+              <a:spcBef>
+                <a:spcPct val="0"/>
+              </a:spcBef>
+              <a:buAutoNum type="arabicPeriod"/>
+            </a:pPr>
+            <a:endParaRPr lang="en-US" sz="3000" dirty="0">
+              <a:solidFill>
+                <a:srgbClr val="000000"/>
+              </a:solidFill>
+              <a:latin typeface="Times New Roman"/>
+              <a:ea typeface="Times New Roman"/>
+              <a:cs typeface="Times New Roman"/>
+              <a:sym typeface="Times New Roman"/>
+            </a:endParaRPr>
+          </a:p>
+        </p:txBody>
+      </p:sp>
+      <p:sp>
+        <p:nvSpPr>
+          <p:cNvPr id="7" name="TextBox 7"/>
+          <p:cNvSpPr txBox="1"/>
+          <p:nvPr/>
+        </p:nvSpPr>
+        <p:spPr>
+          <a:xfrm>
+            <a:off x="11611489" y="4224338"/>
+            <a:ext cx="5949255" cy="5341590"/>
+          </a:xfrm>
+          <a:prstGeom prst="rect">
+            <a:avLst/>
+          </a:prstGeom>
+        </p:spPr>
+        <p:txBody>
+          <a:bodyPr lIns="0" tIns="0" rIns="0" bIns="0" rtlCol="0" anchor="t">
+            <a:spAutoFit/>
+          </a:bodyPr>
+          <a:lstStyle/>
+          <a:p>
+            <a:pPr algn="ctr">
+              <a:lnSpc>
+                <a:spcPts val="4200"/>
+              </a:lnSpc>
+              <a:spcBef>
+                <a:spcPct val="0"/>
+              </a:spcBef>
+            </a:pPr>
+            <a:r>
+              <a:rPr lang="en-US" sz="3000" dirty="0">
+                <a:solidFill>
+                  <a:srgbClr val="000000"/>
+                </a:solidFill>
+                <a:latin typeface="Times New Roman"/>
+                <a:ea typeface="Times New Roman"/>
+                <a:cs typeface="Times New Roman"/>
+                <a:sym typeface="Times New Roman"/>
+              </a:rPr>
+              <a:t>5. Nguyễn Hoàng </a:t>
+            </a:r>
+            <a:r>
+              <a:rPr lang="en-US" sz="3000" dirty="0" err="1">
+                <a:solidFill>
+                  <a:srgbClr val="000000"/>
+                </a:solidFill>
+                <a:latin typeface="Times New Roman"/>
+                <a:ea typeface="Times New Roman"/>
+                <a:cs typeface="Times New Roman"/>
+                <a:sym typeface="Times New Roman"/>
+              </a:rPr>
+              <a:t>Nhựt</a:t>
+            </a:r>
+            <a:r>
+              <a:rPr lang="en-US" sz="3000" dirty="0">
+                <a:solidFill>
+                  <a:srgbClr val="000000"/>
+                </a:solidFill>
+                <a:latin typeface="Times New Roman"/>
+                <a:ea typeface="Times New Roman"/>
+                <a:cs typeface="Times New Roman"/>
+                <a:sym typeface="Times New Roman"/>
+              </a:rPr>
+              <a:t> </a:t>
+            </a:r>
+            <a:r>
+              <a:rPr lang="en-US" sz="3000" dirty="0" err="1">
+                <a:solidFill>
+                  <a:srgbClr val="000000"/>
+                </a:solidFill>
+                <a:latin typeface="Times New Roman"/>
+                <a:ea typeface="Times New Roman"/>
+                <a:cs typeface="Times New Roman"/>
+                <a:sym typeface="Times New Roman"/>
+              </a:rPr>
+              <a:t>Phát</a:t>
+            </a:r>
+            <a:r>
+              <a:rPr lang="en-US" sz="3000" dirty="0">
+                <a:solidFill>
+                  <a:srgbClr val="000000"/>
+                </a:solidFill>
+                <a:latin typeface="Times New Roman"/>
+                <a:ea typeface="Times New Roman"/>
+                <a:cs typeface="Times New Roman"/>
+                <a:sym typeface="Times New Roman"/>
+              </a:rPr>
+              <a:t> 2251150070</a:t>
+            </a:r>
+          </a:p>
+          <a:p>
+            <a:pPr algn="ctr">
+              <a:lnSpc>
+                <a:spcPts val="4200"/>
+              </a:lnSpc>
+              <a:spcBef>
+                <a:spcPct val="0"/>
+              </a:spcBef>
+            </a:pPr>
+            <a:endParaRPr lang="en-US" sz="3000" dirty="0">
+              <a:solidFill>
+                <a:srgbClr val="000000"/>
+              </a:solidFill>
+              <a:latin typeface="Times New Roman"/>
+              <a:ea typeface="Times New Roman"/>
+              <a:cs typeface="Times New Roman"/>
+              <a:sym typeface="Times New Roman"/>
+            </a:endParaRPr>
+          </a:p>
+          <a:p>
+            <a:pPr algn="ctr">
+              <a:lnSpc>
+                <a:spcPts val="4200"/>
+              </a:lnSpc>
+              <a:spcBef>
+                <a:spcPct val="0"/>
+              </a:spcBef>
+            </a:pPr>
+            <a:endParaRPr lang="en-US" sz="3000" dirty="0">
+              <a:solidFill>
+                <a:srgbClr val="000000"/>
+              </a:solidFill>
+              <a:latin typeface="Times New Roman"/>
+              <a:ea typeface="Times New Roman"/>
+              <a:cs typeface="Times New Roman"/>
+              <a:sym typeface="Times New Roman"/>
+            </a:endParaRPr>
+          </a:p>
+          <a:p>
+            <a:pPr algn="ctr">
+              <a:lnSpc>
+                <a:spcPts val="4200"/>
+              </a:lnSpc>
+              <a:spcBef>
+                <a:spcPct val="0"/>
+              </a:spcBef>
+            </a:pPr>
+            <a:endParaRPr lang="en-US" sz="3000" dirty="0">
+              <a:solidFill>
+                <a:srgbClr val="000000"/>
+              </a:solidFill>
+              <a:latin typeface="Times New Roman"/>
+              <a:ea typeface="Times New Roman"/>
+              <a:cs typeface="Times New Roman"/>
+              <a:sym typeface="Times New Roman"/>
+            </a:endParaRPr>
+          </a:p>
+          <a:p>
+            <a:pPr algn="ctr">
+              <a:lnSpc>
+                <a:spcPts val="4200"/>
+              </a:lnSpc>
+              <a:spcBef>
+                <a:spcPct val="0"/>
+              </a:spcBef>
+            </a:pPr>
+            <a:endParaRPr lang="en-US" sz="3000" dirty="0">
+              <a:solidFill>
+                <a:srgbClr val="000000"/>
+              </a:solidFill>
+              <a:latin typeface="Times New Roman"/>
+              <a:ea typeface="Times New Roman"/>
+              <a:cs typeface="Times New Roman"/>
+              <a:sym typeface="Times New Roman"/>
+            </a:endParaRPr>
+          </a:p>
+          <a:p>
+            <a:pPr algn="ctr">
+              <a:lnSpc>
+                <a:spcPts val="4200"/>
+              </a:lnSpc>
+              <a:spcBef>
+                <a:spcPct val="0"/>
+              </a:spcBef>
+            </a:pPr>
+            <a:r>
+              <a:rPr lang="en-US" sz="3000" dirty="0">
+                <a:solidFill>
+                  <a:srgbClr val="000000"/>
+                </a:solidFill>
+                <a:latin typeface="Times New Roman"/>
+                <a:ea typeface="Times New Roman"/>
+                <a:cs typeface="Times New Roman"/>
+                <a:sym typeface="Times New Roman"/>
+              </a:rPr>
+              <a:t>6. </a:t>
+            </a:r>
+            <a:r>
+              <a:rPr lang="en-US" sz="3000" dirty="0" err="1">
+                <a:solidFill>
+                  <a:srgbClr val="000000"/>
+                </a:solidFill>
+                <a:latin typeface="Times New Roman"/>
+                <a:ea typeface="Times New Roman"/>
+                <a:cs typeface="Times New Roman"/>
+                <a:sym typeface="Times New Roman"/>
+              </a:rPr>
+              <a:t>Trần</a:t>
+            </a:r>
+            <a:r>
+              <a:rPr lang="en-US" sz="3000" dirty="0">
+                <a:solidFill>
+                  <a:srgbClr val="000000"/>
+                </a:solidFill>
+                <a:latin typeface="Times New Roman"/>
+                <a:ea typeface="Times New Roman"/>
+                <a:cs typeface="Times New Roman"/>
+                <a:sym typeface="Times New Roman"/>
+              </a:rPr>
+              <a:t> Cao Minh</a:t>
+            </a:r>
+          </a:p>
+          <a:p>
+            <a:pPr algn="ctr">
+              <a:lnSpc>
+                <a:spcPts val="4200"/>
+              </a:lnSpc>
+              <a:spcBef>
+                <a:spcPct val="0"/>
+              </a:spcBef>
+            </a:pPr>
+            <a:r>
+              <a:rPr lang="en-US" sz="3000" dirty="0">
+                <a:solidFill>
+                  <a:srgbClr val="000000"/>
+                </a:solidFill>
+                <a:latin typeface="Times New Roman"/>
+                <a:ea typeface="Times New Roman"/>
+                <a:cs typeface="Times New Roman"/>
+                <a:sym typeface="Times New Roman"/>
+              </a:rPr>
+              <a:t>080206005146</a:t>
+            </a:r>
+          </a:p>
+          <a:p>
+            <a:pPr algn="ctr">
+              <a:lnSpc>
+                <a:spcPts val="4200"/>
+              </a:lnSpc>
+              <a:spcBef>
+                <a:spcPct val="0"/>
+              </a:spcBef>
+            </a:pPr>
+            <a:endParaRPr lang="en-US" sz="3000" dirty="0">
+              <a:solidFill>
+                <a:srgbClr val="000000"/>
+              </a:solidFill>
+              <a:latin typeface="Times New Roman"/>
+              <a:ea typeface="Times New Roman"/>
+              <a:cs typeface="Times New Roman"/>
+              <a:sym typeface="Times New Roman"/>
+            </a:endParaRPr>
+          </a:p>
+          <a:p>
+            <a:pPr algn="ctr">
+              <a:lnSpc>
+                <a:spcPts val="4200"/>
+              </a:lnSpc>
+              <a:spcBef>
+                <a:spcPct val="0"/>
+              </a:spcBef>
+            </a:pPr>
+            <a:endParaRPr lang="en-US" sz="3000" dirty="0">
+              <a:solidFill>
+                <a:srgbClr val="000000"/>
+              </a:solidFill>
+              <a:latin typeface="Times New Roman"/>
+              <a:ea typeface="Times New Roman"/>
+              <a:cs typeface="Times New Roman"/>
+              <a:sym typeface="Times New Roman"/>
+            </a:endParaRPr>
+          </a:p>
+        </p:txBody>
+      </p:sp>
+      <p:sp>
+        <p:nvSpPr>
+          <p:cNvPr id="8" name="TextBox 8"/>
+          <p:cNvSpPr txBox="1"/>
+          <p:nvPr/>
+        </p:nvSpPr>
+        <p:spPr>
+          <a:xfrm>
+            <a:off x="7180956" y="4229100"/>
+            <a:ext cx="3926086" cy="4802981"/>
+          </a:xfrm>
+          <a:prstGeom prst="rect">
+            <a:avLst/>
+          </a:prstGeom>
+        </p:spPr>
+        <p:txBody>
+          <a:bodyPr lIns="0" tIns="0" rIns="0" bIns="0" rtlCol="0" anchor="t">
+            <a:spAutoFit/>
+          </a:bodyPr>
+          <a:lstStyle/>
+          <a:p>
+            <a:pPr algn="ctr">
+              <a:lnSpc>
+                <a:spcPts val="4200"/>
+              </a:lnSpc>
+            </a:pPr>
+            <a:r>
+              <a:rPr lang="en-US" sz="3000" dirty="0">
+                <a:solidFill>
+                  <a:srgbClr val="000000"/>
+                </a:solidFill>
+                <a:latin typeface="Times New Roman"/>
+                <a:ea typeface="Times New Roman"/>
+                <a:cs typeface="Times New Roman"/>
+                <a:sym typeface="Times New Roman"/>
+              </a:rPr>
+              <a:t>3. Vũ Văn Kiệt 2251150059</a:t>
+            </a:r>
+          </a:p>
+          <a:p>
+            <a:pPr algn="ctr">
+              <a:lnSpc>
+                <a:spcPts val="4200"/>
+              </a:lnSpc>
+              <a:spcBef>
+                <a:spcPct val="0"/>
+              </a:spcBef>
+            </a:pPr>
+            <a:r>
+              <a:rPr lang="en-US" sz="3000" dirty="0">
+                <a:solidFill>
+                  <a:srgbClr val="000000"/>
+                </a:solidFill>
+                <a:latin typeface="Times New Roman"/>
+                <a:ea typeface="Times New Roman"/>
+                <a:cs typeface="Times New Roman"/>
+                <a:sym typeface="Times New Roman"/>
+              </a:rPr>
+              <a:t>(NT)</a:t>
+            </a:r>
+          </a:p>
+          <a:p>
+            <a:pPr algn="ctr">
+              <a:lnSpc>
+                <a:spcPts val="4200"/>
+              </a:lnSpc>
+              <a:spcBef>
+                <a:spcPct val="0"/>
+              </a:spcBef>
+            </a:pPr>
+            <a:endParaRPr lang="en-US" sz="3000" dirty="0">
+              <a:solidFill>
+                <a:srgbClr val="000000"/>
+              </a:solidFill>
+              <a:latin typeface="Times New Roman"/>
+              <a:ea typeface="Times New Roman"/>
+              <a:cs typeface="Times New Roman"/>
+              <a:sym typeface="Times New Roman"/>
+            </a:endParaRPr>
+          </a:p>
+          <a:p>
+            <a:pPr algn="ctr">
+              <a:lnSpc>
+                <a:spcPts val="4200"/>
+              </a:lnSpc>
+              <a:spcBef>
+                <a:spcPct val="0"/>
+              </a:spcBef>
+            </a:pPr>
+            <a:endParaRPr lang="en-US" sz="3000" dirty="0">
+              <a:solidFill>
+                <a:srgbClr val="000000"/>
+              </a:solidFill>
+              <a:latin typeface="Times New Roman"/>
+              <a:ea typeface="Times New Roman"/>
+              <a:cs typeface="Times New Roman"/>
+              <a:sym typeface="Times New Roman"/>
+            </a:endParaRPr>
+          </a:p>
+          <a:p>
+            <a:pPr algn="ctr">
+              <a:lnSpc>
+                <a:spcPts val="4200"/>
+              </a:lnSpc>
+              <a:spcBef>
+                <a:spcPct val="0"/>
+              </a:spcBef>
+            </a:pPr>
+            <a:endParaRPr lang="en-US" sz="3000" dirty="0">
+              <a:solidFill>
+                <a:srgbClr val="000000"/>
+              </a:solidFill>
+              <a:latin typeface="Times New Roman"/>
+              <a:ea typeface="Times New Roman"/>
+              <a:cs typeface="Times New Roman"/>
+              <a:sym typeface="Times New Roman"/>
+            </a:endParaRPr>
+          </a:p>
+          <a:p>
+            <a:pPr algn="ctr">
+              <a:lnSpc>
+                <a:spcPts val="4200"/>
+              </a:lnSpc>
+              <a:spcBef>
+                <a:spcPct val="0"/>
+              </a:spcBef>
+            </a:pPr>
+            <a:r>
+              <a:rPr lang="en-US" sz="3000" dirty="0">
+                <a:solidFill>
+                  <a:srgbClr val="000000"/>
+                </a:solidFill>
+                <a:latin typeface="Times New Roman"/>
+                <a:ea typeface="Times New Roman"/>
+                <a:cs typeface="Times New Roman"/>
+                <a:sym typeface="Times New Roman"/>
+              </a:rPr>
+              <a:t>      4. </a:t>
+            </a:r>
+            <a:r>
+              <a:rPr lang="en-US" sz="3000" dirty="0" err="1">
+                <a:solidFill>
+                  <a:srgbClr val="000000"/>
+                </a:solidFill>
+                <a:latin typeface="Times New Roman"/>
+                <a:ea typeface="Times New Roman"/>
+                <a:cs typeface="Times New Roman"/>
+                <a:sym typeface="Times New Roman"/>
+              </a:rPr>
+              <a:t>Trần</a:t>
+            </a:r>
+            <a:r>
+              <a:rPr lang="en-US" sz="3000" dirty="0">
+                <a:solidFill>
+                  <a:srgbClr val="000000"/>
+                </a:solidFill>
+                <a:latin typeface="Times New Roman"/>
+                <a:ea typeface="Times New Roman"/>
+                <a:cs typeface="Times New Roman"/>
+                <a:sym typeface="Times New Roman"/>
+              </a:rPr>
+              <a:t> Hoàng Nam</a:t>
+            </a:r>
+          </a:p>
+          <a:p>
+            <a:pPr algn="ctr">
+              <a:lnSpc>
+                <a:spcPts val="4200"/>
+              </a:lnSpc>
+              <a:spcBef>
+                <a:spcPct val="0"/>
+              </a:spcBef>
+            </a:pPr>
+            <a:r>
+              <a:rPr lang="en-US" sz="3000" dirty="0">
+                <a:solidFill>
+                  <a:srgbClr val="000000"/>
+                </a:solidFill>
+                <a:latin typeface="Times New Roman"/>
+                <a:ea typeface="Times New Roman"/>
+                <a:cs typeface="Times New Roman"/>
+                <a:sym typeface="Times New Roman"/>
+              </a:rPr>
+              <a:t>    068206000088</a:t>
+            </a:r>
+          </a:p>
+          <a:p>
+            <a:pPr algn="ctr">
+              <a:lnSpc>
+                <a:spcPts val="4200"/>
+              </a:lnSpc>
+              <a:spcBef>
+                <a:spcPct val="0"/>
+              </a:spcBef>
+            </a:pPr>
+            <a:endParaRPr lang="en-US" sz="3000" dirty="0">
+              <a:solidFill>
+                <a:srgbClr val="000000"/>
+              </a:solidFill>
+              <a:latin typeface="Times New Roman"/>
+              <a:ea typeface="Times New Roman"/>
+              <a:cs typeface="Times New Roman"/>
+              <a:sym typeface="Times New Roman"/>
+            </a:endParaRPr>
+          </a:p>
+        </p:txBody>
+      </p:sp>
+      <p:sp>
+        <p:nvSpPr>
+          <p:cNvPr id="9" name="TextBox 6">
+            <a:extLst>
+              <a:ext uri="{FF2B5EF4-FFF2-40B4-BE49-F238E27FC236}">
+                <a16:creationId xmlns:a16="http://schemas.microsoft.com/office/drawing/2014/main" id="{BE68BD4F-A958-4C5A-AE89-68469B74C4CE}"/>
+              </a:ext>
+            </a:extLst>
+          </p:cNvPr>
+          <p:cNvSpPr txBox="1"/>
+          <p:nvPr/>
+        </p:nvSpPr>
+        <p:spPr>
+          <a:xfrm>
+            <a:off x="6669583" y="3238500"/>
+            <a:ext cx="4948833" cy="538609"/>
+          </a:xfrm>
+          <a:prstGeom prst="rect">
+            <a:avLst/>
+          </a:prstGeom>
+        </p:spPr>
+        <p:txBody>
+          <a:bodyPr lIns="0" tIns="0" rIns="0" bIns="0" rtlCol="0" anchor="t">
+            <a:spAutoFit/>
+          </a:bodyPr>
+          <a:lstStyle/>
+          <a:p>
+            <a:pPr algn="ctr">
+              <a:lnSpc>
+                <a:spcPts val="4200"/>
+              </a:lnSpc>
+              <a:spcBef>
+                <a:spcPct val="0"/>
+              </a:spcBef>
+            </a:pPr>
+            <a:r>
+              <a:rPr lang="en-US" sz="4000" b="1" dirty="0">
+                <a:solidFill>
+                  <a:srgbClr val="000000"/>
+                </a:solidFill>
+                <a:latin typeface="Times New Roman"/>
+                <a:ea typeface="Times New Roman"/>
+                <a:cs typeface="Times New Roman"/>
+                <a:sym typeface="Times New Roman"/>
+              </a:rPr>
+              <a:t>NHÓM 3</a:t>
+            </a:r>
+          </a:p>
+        </p:txBody>
+      </p:sp>
+    </p:spTree>
+  </p:cSld>
+  <p:clrMapOvr>
+    <a:masterClrMapping/>
+  </p:clrMapOvr>
+</p:sld>
+</file>
+
+<file path=ppt/slides/slide20.xml><?xml version="1.0" encoding="utf-8"?>
 <p:sld xmlns:a="http://schemas.openxmlformats.org/drawingml/2006/main" xmlns:r="http://schemas.openxmlformats.org/officeDocument/2006/relationships" xmlns:p="http://schemas.openxmlformats.org/presentationml/2006/main">
   <p:cSld>
     <p:spTree>
@@ -9430,821 +10541,7 @@
 </p:sld>
 </file>
 
-<file path=ppt/slides/slide2.xml><?xml version="1.0" encoding="utf-8"?>
-<p:sld xmlns:a="http://schemas.openxmlformats.org/drawingml/2006/main" xmlns:r="http://schemas.openxmlformats.org/officeDocument/2006/relationships" xmlns:p="http://schemas.openxmlformats.org/presentationml/2006/main">
-  <p:cSld>
-    <p:spTree>
-      <p:nvGrpSpPr>
-        <p:cNvPr id="1" name=""/>
-        <p:cNvGrpSpPr/>
-        <p:nvPr/>
-      </p:nvGrpSpPr>
-      <p:grpSpPr>
-        <a:xfrm>
-          <a:off x="0" y="0"/>
-          <a:ext cx="0" cy="0"/>
-          <a:chOff x="0" y="0"/>
-          <a:chExt cx="0" cy="0"/>
-        </a:xfrm>
-      </p:grpSpPr>
-      <p:sp>
-        <p:nvSpPr>
-          <p:cNvPr id="2" name="Freeform 2"/>
-          <p:cNvSpPr/>
-          <p:nvPr/>
-        </p:nvSpPr>
-        <p:spPr>
-          <a:xfrm>
-            <a:off x="-32657" y="-128736"/>
-            <a:ext cx="18288000" cy="10287000"/>
-          </a:xfrm>
-          <a:custGeom>
-            <a:avLst/>
-            <a:gdLst/>
-            <a:ahLst/>
-            <a:cxnLst/>
-            <a:rect l="l" t="t" r="r" b="b"/>
-            <a:pathLst>
-              <a:path w="18288000" h="10287000">
-                <a:moveTo>
-                  <a:pt x="0" y="0"/>
-                </a:moveTo>
-                <a:lnTo>
-                  <a:pt x="18288000" y="0"/>
-                </a:lnTo>
-                <a:lnTo>
-                  <a:pt x="18288000" y="10287000"/>
-                </a:lnTo>
-                <a:lnTo>
-                  <a:pt x="0" y="10287000"/>
-                </a:lnTo>
-                <a:lnTo>
-                  <a:pt x="0" y="0"/>
-                </a:lnTo>
-                <a:close/>
-              </a:path>
-            </a:pathLst>
-          </a:custGeom>
-          <a:blipFill>
-            <a:blip r:embed="rId2"/>
-            <a:stretch>
-              <a:fillRect/>
-            </a:stretch>
-          </a:blipFill>
-        </p:spPr>
-        <p:txBody>
-          <a:bodyPr/>
-          <a:lstStyle/>
-          <a:p>
-            <a:endParaRPr lang="en-US" dirty="0"/>
-          </a:p>
-        </p:txBody>
-      </p:sp>
-      <p:sp>
-        <p:nvSpPr>
-          <p:cNvPr id="6" name="TextBox 6"/>
-          <p:cNvSpPr txBox="1"/>
-          <p:nvPr/>
-        </p:nvSpPr>
-        <p:spPr>
-          <a:xfrm>
-            <a:off x="1600200" y="4229100"/>
-            <a:ext cx="4886157" cy="4802981"/>
-          </a:xfrm>
-          <a:prstGeom prst="rect">
-            <a:avLst/>
-          </a:prstGeom>
-        </p:spPr>
-        <p:txBody>
-          <a:bodyPr wrap="square" lIns="0" tIns="0" rIns="0" bIns="0" rtlCol="0" anchor="t">
-            <a:spAutoFit/>
-          </a:bodyPr>
-          <a:lstStyle/>
-          <a:p>
-            <a:pPr algn="ctr">
-              <a:lnSpc>
-                <a:spcPts val="4200"/>
-              </a:lnSpc>
-              <a:spcBef>
-                <a:spcPct val="0"/>
-              </a:spcBef>
-            </a:pPr>
-            <a:r>
-              <a:rPr lang="en-US" sz="3000" dirty="0">
-                <a:solidFill>
-                  <a:srgbClr val="000000"/>
-                </a:solidFill>
-                <a:latin typeface="Times New Roman"/>
-                <a:ea typeface="Times New Roman"/>
-                <a:cs typeface="Times New Roman"/>
-                <a:sym typeface="Times New Roman"/>
-              </a:rPr>
-              <a:t>1. Trịnh Văn </a:t>
-            </a:r>
-            <a:r>
-              <a:rPr lang="en-US" sz="3000" dirty="0" err="1">
-                <a:solidFill>
-                  <a:srgbClr val="000000"/>
-                </a:solidFill>
-                <a:latin typeface="Times New Roman"/>
-                <a:ea typeface="Times New Roman"/>
-                <a:cs typeface="Times New Roman"/>
-                <a:sym typeface="Times New Roman"/>
-              </a:rPr>
-              <a:t>Thưởng</a:t>
-            </a:r>
-            <a:r>
-              <a:rPr lang="en-US" sz="3000" dirty="0">
-                <a:solidFill>
-                  <a:srgbClr val="000000"/>
-                </a:solidFill>
-                <a:latin typeface="Times New Roman"/>
-                <a:ea typeface="Times New Roman"/>
-                <a:cs typeface="Times New Roman"/>
-                <a:sym typeface="Times New Roman"/>
-              </a:rPr>
-              <a:t> 2251150081</a:t>
-            </a:r>
-          </a:p>
-          <a:p>
-            <a:pPr algn="ctr">
-              <a:lnSpc>
-                <a:spcPts val="4200"/>
-              </a:lnSpc>
-              <a:spcBef>
-                <a:spcPct val="0"/>
-              </a:spcBef>
-            </a:pPr>
-            <a:endParaRPr lang="en-US" sz="3000" dirty="0">
-              <a:solidFill>
-                <a:srgbClr val="000000"/>
-              </a:solidFill>
-              <a:latin typeface="Times New Roman"/>
-              <a:ea typeface="Times New Roman"/>
-              <a:cs typeface="Times New Roman"/>
-              <a:sym typeface="Times New Roman"/>
-            </a:endParaRPr>
-          </a:p>
-          <a:p>
-            <a:pPr algn="ctr">
-              <a:lnSpc>
-                <a:spcPts val="4200"/>
-              </a:lnSpc>
-              <a:spcBef>
-                <a:spcPct val="0"/>
-              </a:spcBef>
-            </a:pPr>
-            <a:endParaRPr lang="en-US" sz="3000" dirty="0">
-              <a:solidFill>
-                <a:srgbClr val="000000"/>
-              </a:solidFill>
-              <a:latin typeface="Times New Roman"/>
-              <a:ea typeface="Times New Roman"/>
-              <a:cs typeface="Times New Roman"/>
-              <a:sym typeface="Times New Roman"/>
-            </a:endParaRPr>
-          </a:p>
-          <a:p>
-            <a:pPr algn="ctr">
-              <a:lnSpc>
-                <a:spcPts val="4200"/>
-              </a:lnSpc>
-              <a:spcBef>
-                <a:spcPct val="0"/>
-              </a:spcBef>
-            </a:pPr>
-            <a:endParaRPr lang="en-US" sz="3000" dirty="0">
-              <a:solidFill>
-                <a:srgbClr val="000000"/>
-              </a:solidFill>
-              <a:latin typeface="Times New Roman"/>
-              <a:ea typeface="Times New Roman"/>
-              <a:cs typeface="Times New Roman"/>
-              <a:sym typeface="Times New Roman"/>
-            </a:endParaRPr>
-          </a:p>
-          <a:p>
-            <a:pPr algn="ctr">
-              <a:lnSpc>
-                <a:spcPts val="4200"/>
-              </a:lnSpc>
-              <a:spcBef>
-                <a:spcPct val="0"/>
-              </a:spcBef>
-            </a:pPr>
-            <a:endParaRPr lang="en-US" sz="3000" dirty="0">
-              <a:solidFill>
-                <a:srgbClr val="000000"/>
-              </a:solidFill>
-              <a:latin typeface="Times New Roman"/>
-              <a:ea typeface="Times New Roman"/>
-              <a:cs typeface="Times New Roman"/>
-              <a:sym typeface="Times New Roman"/>
-            </a:endParaRPr>
-          </a:p>
-          <a:p>
-            <a:pPr algn="ctr">
-              <a:lnSpc>
-                <a:spcPts val="4200"/>
-              </a:lnSpc>
-              <a:spcBef>
-                <a:spcPct val="0"/>
-              </a:spcBef>
-            </a:pPr>
-            <a:r>
-              <a:rPr lang="en-US" sz="3000" dirty="0">
-                <a:solidFill>
-                  <a:srgbClr val="000000"/>
-                </a:solidFill>
-                <a:latin typeface="Times New Roman"/>
-                <a:ea typeface="Times New Roman"/>
-                <a:cs typeface="Times New Roman"/>
-                <a:sym typeface="Times New Roman"/>
-              </a:rPr>
-              <a:t>2. Nguyễn Thành Đạt</a:t>
-            </a:r>
-          </a:p>
-          <a:p>
-            <a:pPr algn="ctr">
-              <a:lnSpc>
-                <a:spcPts val="4200"/>
-              </a:lnSpc>
-              <a:spcBef>
-                <a:spcPct val="0"/>
-              </a:spcBef>
-            </a:pPr>
-            <a:r>
-              <a:rPr lang="en-US" sz="3000" dirty="0">
-                <a:solidFill>
-                  <a:srgbClr val="000000"/>
-                </a:solidFill>
-                <a:latin typeface="Times New Roman"/>
-                <a:ea typeface="Times New Roman"/>
-                <a:cs typeface="Times New Roman"/>
-                <a:sym typeface="Times New Roman"/>
-              </a:rPr>
-              <a:t>058206008394</a:t>
-            </a:r>
-          </a:p>
-          <a:p>
-            <a:pPr marL="514350" indent="-514350" algn="ctr">
-              <a:lnSpc>
-                <a:spcPts val="4200"/>
-              </a:lnSpc>
-              <a:spcBef>
-                <a:spcPct val="0"/>
-              </a:spcBef>
-              <a:buAutoNum type="arabicPeriod"/>
-            </a:pPr>
-            <a:endParaRPr lang="en-US" sz="3000" dirty="0">
-              <a:solidFill>
-                <a:srgbClr val="000000"/>
-              </a:solidFill>
-              <a:latin typeface="Times New Roman"/>
-              <a:ea typeface="Times New Roman"/>
-              <a:cs typeface="Times New Roman"/>
-              <a:sym typeface="Times New Roman"/>
-            </a:endParaRPr>
-          </a:p>
-        </p:txBody>
-      </p:sp>
-      <p:sp>
-        <p:nvSpPr>
-          <p:cNvPr id="7" name="TextBox 7"/>
-          <p:cNvSpPr txBox="1"/>
-          <p:nvPr/>
-        </p:nvSpPr>
-        <p:spPr>
-          <a:xfrm>
-            <a:off x="11611489" y="4224338"/>
-            <a:ext cx="5949255" cy="5341590"/>
-          </a:xfrm>
-          <a:prstGeom prst="rect">
-            <a:avLst/>
-          </a:prstGeom>
-        </p:spPr>
-        <p:txBody>
-          <a:bodyPr lIns="0" tIns="0" rIns="0" bIns="0" rtlCol="0" anchor="t">
-            <a:spAutoFit/>
-          </a:bodyPr>
-          <a:lstStyle/>
-          <a:p>
-            <a:pPr algn="ctr">
-              <a:lnSpc>
-                <a:spcPts val="4200"/>
-              </a:lnSpc>
-              <a:spcBef>
-                <a:spcPct val="0"/>
-              </a:spcBef>
-            </a:pPr>
-            <a:r>
-              <a:rPr lang="en-US" sz="3000" dirty="0">
-                <a:solidFill>
-                  <a:srgbClr val="000000"/>
-                </a:solidFill>
-                <a:latin typeface="Times New Roman"/>
-                <a:ea typeface="Times New Roman"/>
-                <a:cs typeface="Times New Roman"/>
-                <a:sym typeface="Times New Roman"/>
-              </a:rPr>
-              <a:t>5. Nguyễn Hoàng </a:t>
-            </a:r>
-            <a:r>
-              <a:rPr lang="en-US" sz="3000" dirty="0" err="1">
-                <a:solidFill>
-                  <a:srgbClr val="000000"/>
-                </a:solidFill>
-                <a:latin typeface="Times New Roman"/>
-                <a:ea typeface="Times New Roman"/>
-                <a:cs typeface="Times New Roman"/>
-                <a:sym typeface="Times New Roman"/>
-              </a:rPr>
-              <a:t>Nhựt</a:t>
-            </a:r>
-            <a:r>
-              <a:rPr lang="en-US" sz="3000" dirty="0">
-                <a:solidFill>
-                  <a:srgbClr val="000000"/>
-                </a:solidFill>
-                <a:latin typeface="Times New Roman"/>
-                <a:ea typeface="Times New Roman"/>
-                <a:cs typeface="Times New Roman"/>
-                <a:sym typeface="Times New Roman"/>
-              </a:rPr>
-              <a:t> </a:t>
-            </a:r>
-            <a:r>
-              <a:rPr lang="en-US" sz="3000" dirty="0" err="1">
-                <a:solidFill>
-                  <a:srgbClr val="000000"/>
-                </a:solidFill>
-                <a:latin typeface="Times New Roman"/>
-                <a:ea typeface="Times New Roman"/>
-                <a:cs typeface="Times New Roman"/>
-                <a:sym typeface="Times New Roman"/>
-              </a:rPr>
-              <a:t>Phát</a:t>
-            </a:r>
-            <a:r>
-              <a:rPr lang="en-US" sz="3000" dirty="0">
-                <a:solidFill>
-                  <a:srgbClr val="000000"/>
-                </a:solidFill>
-                <a:latin typeface="Times New Roman"/>
-                <a:ea typeface="Times New Roman"/>
-                <a:cs typeface="Times New Roman"/>
-                <a:sym typeface="Times New Roman"/>
-              </a:rPr>
-              <a:t> 2251150070</a:t>
-            </a:r>
-          </a:p>
-          <a:p>
-            <a:pPr algn="ctr">
-              <a:lnSpc>
-                <a:spcPts val="4200"/>
-              </a:lnSpc>
-              <a:spcBef>
-                <a:spcPct val="0"/>
-              </a:spcBef>
-            </a:pPr>
-            <a:endParaRPr lang="en-US" sz="3000" dirty="0">
-              <a:solidFill>
-                <a:srgbClr val="000000"/>
-              </a:solidFill>
-              <a:latin typeface="Times New Roman"/>
-              <a:ea typeface="Times New Roman"/>
-              <a:cs typeface="Times New Roman"/>
-              <a:sym typeface="Times New Roman"/>
-            </a:endParaRPr>
-          </a:p>
-          <a:p>
-            <a:pPr algn="ctr">
-              <a:lnSpc>
-                <a:spcPts val="4200"/>
-              </a:lnSpc>
-              <a:spcBef>
-                <a:spcPct val="0"/>
-              </a:spcBef>
-            </a:pPr>
-            <a:endParaRPr lang="en-US" sz="3000" dirty="0">
-              <a:solidFill>
-                <a:srgbClr val="000000"/>
-              </a:solidFill>
-              <a:latin typeface="Times New Roman"/>
-              <a:ea typeface="Times New Roman"/>
-              <a:cs typeface="Times New Roman"/>
-              <a:sym typeface="Times New Roman"/>
-            </a:endParaRPr>
-          </a:p>
-          <a:p>
-            <a:pPr algn="ctr">
-              <a:lnSpc>
-                <a:spcPts val="4200"/>
-              </a:lnSpc>
-              <a:spcBef>
-                <a:spcPct val="0"/>
-              </a:spcBef>
-            </a:pPr>
-            <a:endParaRPr lang="en-US" sz="3000" dirty="0">
-              <a:solidFill>
-                <a:srgbClr val="000000"/>
-              </a:solidFill>
-              <a:latin typeface="Times New Roman"/>
-              <a:ea typeface="Times New Roman"/>
-              <a:cs typeface="Times New Roman"/>
-              <a:sym typeface="Times New Roman"/>
-            </a:endParaRPr>
-          </a:p>
-          <a:p>
-            <a:pPr algn="ctr">
-              <a:lnSpc>
-                <a:spcPts val="4200"/>
-              </a:lnSpc>
-              <a:spcBef>
-                <a:spcPct val="0"/>
-              </a:spcBef>
-            </a:pPr>
-            <a:endParaRPr lang="en-US" sz="3000" dirty="0">
-              <a:solidFill>
-                <a:srgbClr val="000000"/>
-              </a:solidFill>
-              <a:latin typeface="Times New Roman"/>
-              <a:ea typeface="Times New Roman"/>
-              <a:cs typeface="Times New Roman"/>
-              <a:sym typeface="Times New Roman"/>
-            </a:endParaRPr>
-          </a:p>
-          <a:p>
-            <a:pPr algn="ctr">
-              <a:lnSpc>
-                <a:spcPts val="4200"/>
-              </a:lnSpc>
-              <a:spcBef>
-                <a:spcPct val="0"/>
-              </a:spcBef>
-            </a:pPr>
-            <a:r>
-              <a:rPr lang="en-US" sz="3000" dirty="0">
-                <a:solidFill>
-                  <a:srgbClr val="000000"/>
-                </a:solidFill>
-                <a:latin typeface="Times New Roman"/>
-                <a:ea typeface="Times New Roman"/>
-                <a:cs typeface="Times New Roman"/>
-                <a:sym typeface="Times New Roman"/>
-              </a:rPr>
-              <a:t>6. </a:t>
-            </a:r>
-            <a:r>
-              <a:rPr lang="en-US" sz="3000" dirty="0" err="1">
-                <a:solidFill>
-                  <a:srgbClr val="000000"/>
-                </a:solidFill>
-                <a:latin typeface="Times New Roman"/>
-                <a:ea typeface="Times New Roman"/>
-                <a:cs typeface="Times New Roman"/>
-                <a:sym typeface="Times New Roman"/>
-              </a:rPr>
-              <a:t>Trần</a:t>
-            </a:r>
-            <a:r>
-              <a:rPr lang="en-US" sz="3000" dirty="0">
-                <a:solidFill>
-                  <a:srgbClr val="000000"/>
-                </a:solidFill>
-                <a:latin typeface="Times New Roman"/>
-                <a:ea typeface="Times New Roman"/>
-                <a:cs typeface="Times New Roman"/>
-                <a:sym typeface="Times New Roman"/>
-              </a:rPr>
-              <a:t> Cao Minh</a:t>
-            </a:r>
-          </a:p>
-          <a:p>
-            <a:pPr algn="ctr">
-              <a:lnSpc>
-                <a:spcPts val="4200"/>
-              </a:lnSpc>
-              <a:spcBef>
-                <a:spcPct val="0"/>
-              </a:spcBef>
-            </a:pPr>
-            <a:endParaRPr lang="en-US" sz="3000" dirty="0">
-              <a:solidFill>
-                <a:srgbClr val="000000"/>
-              </a:solidFill>
-              <a:latin typeface="Times New Roman"/>
-              <a:ea typeface="Times New Roman"/>
-              <a:cs typeface="Times New Roman"/>
-              <a:sym typeface="Times New Roman"/>
-            </a:endParaRPr>
-          </a:p>
-          <a:p>
-            <a:pPr algn="ctr">
-              <a:lnSpc>
-                <a:spcPts val="4200"/>
-              </a:lnSpc>
-              <a:spcBef>
-                <a:spcPct val="0"/>
-              </a:spcBef>
-            </a:pPr>
-            <a:endParaRPr lang="en-US" sz="3000" dirty="0">
-              <a:solidFill>
-                <a:srgbClr val="000000"/>
-              </a:solidFill>
-              <a:latin typeface="Times New Roman"/>
-              <a:ea typeface="Times New Roman"/>
-              <a:cs typeface="Times New Roman"/>
-              <a:sym typeface="Times New Roman"/>
-            </a:endParaRPr>
-          </a:p>
-          <a:p>
-            <a:pPr algn="ctr">
-              <a:lnSpc>
-                <a:spcPts val="4200"/>
-              </a:lnSpc>
-              <a:spcBef>
-                <a:spcPct val="0"/>
-              </a:spcBef>
-            </a:pPr>
-            <a:endParaRPr lang="en-US" sz="3000" dirty="0">
-              <a:solidFill>
-                <a:srgbClr val="000000"/>
-              </a:solidFill>
-              <a:latin typeface="Times New Roman"/>
-              <a:ea typeface="Times New Roman"/>
-              <a:cs typeface="Times New Roman"/>
-              <a:sym typeface="Times New Roman"/>
-            </a:endParaRPr>
-          </a:p>
-        </p:txBody>
-      </p:sp>
-      <p:sp>
-        <p:nvSpPr>
-          <p:cNvPr id="8" name="TextBox 8"/>
-          <p:cNvSpPr txBox="1"/>
-          <p:nvPr/>
-        </p:nvSpPr>
-        <p:spPr>
-          <a:xfrm>
-            <a:off x="7180956" y="4229100"/>
-            <a:ext cx="3926086" cy="4802981"/>
-          </a:xfrm>
-          <a:prstGeom prst="rect">
-            <a:avLst/>
-          </a:prstGeom>
-        </p:spPr>
-        <p:txBody>
-          <a:bodyPr lIns="0" tIns="0" rIns="0" bIns="0" rtlCol="0" anchor="t">
-            <a:spAutoFit/>
-          </a:bodyPr>
-          <a:lstStyle/>
-          <a:p>
-            <a:pPr algn="ctr">
-              <a:lnSpc>
-                <a:spcPts val="4200"/>
-              </a:lnSpc>
-            </a:pPr>
-            <a:r>
-              <a:rPr lang="en-US" sz="3000" dirty="0">
-                <a:solidFill>
-                  <a:srgbClr val="000000"/>
-                </a:solidFill>
-                <a:latin typeface="Times New Roman"/>
-                <a:ea typeface="Times New Roman"/>
-                <a:cs typeface="Times New Roman"/>
-                <a:sym typeface="Times New Roman"/>
-              </a:rPr>
-              <a:t>3. Vũ Văn Kiệt 2251150059</a:t>
-            </a:r>
-          </a:p>
-          <a:p>
-            <a:pPr algn="ctr">
-              <a:lnSpc>
-                <a:spcPts val="4200"/>
-              </a:lnSpc>
-              <a:spcBef>
-                <a:spcPct val="0"/>
-              </a:spcBef>
-            </a:pPr>
-            <a:r>
-              <a:rPr lang="en-US" sz="3000" dirty="0">
-                <a:solidFill>
-                  <a:srgbClr val="000000"/>
-                </a:solidFill>
-                <a:latin typeface="Times New Roman"/>
-                <a:ea typeface="Times New Roman"/>
-                <a:cs typeface="Times New Roman"/>
-                <a:sym typeface="Times New Roman"/>
-              </a:rPr>
-              <a:t>(NT)</a:t>
-            </a:r>
-          </a:p>
-          <a:p>
-            <a:pPr algn="ctr">
-              <a:lnSpc>
-                <a:spcPts val="4200"/>
-              </a:lnSpc>
-              <a:spcBef>
-                <a:spcPct val="0"/>
-              </a:spcBef>
-            </a:pPr>
-            <a:endParaRPr lang="en-US" sz="3000" dirty="0">
-              <a:solidFill>
-                <a:srgbClr val="000000"/>
-              </a:solidFill>
-              <a:latin typeface="Times New Roman"/>
-              <a:ea typeface="Times New Roman"/>
-              <a:cs typeface="Times New Roman"/>
-              <a:sym typeface="Times New Roman"/>
-            </a:endParaRPr>
-          </a:p>
-          <a:p>
-            <a:pPr algn="ctr">
-              <a:lnSpc>
-                <a:spcPts val="4200"/>
-              </a:lnSpc>
-              <a:spcBef>
-                <a:spcPct val="0"/>
-              </a:spcBef>
-            </a:pPr>
-            <a:endParaRPr lang="en-US" sz="3000" dirty="0">
-              <a:solidFill>
-                <a:srgbClr val="000000"/>
-              </a:solidFill>
-              <a:latin typeface="Times New Roman"/>
-              <a:ea typeface="Times New Roman"/>
-              <a:cs typeface="Times New Roman"/>
-              <a:sym typeface="Times New Roman"/>
-            </a:endParaRPr>
-          </a:p>
-          <a:p>
-            <a:pPr algn="ctr">
-              <a:lnSpc>
-                <a:spcPts val="4200"/>
-              </a:lnSpc>
-              <a:spcBef>
-                <a:spcPct val="0"/>
-              </a:spcBef>
-            </a:pPr>
-            <a:endParaRPr lang="en-US" sz="3000" dirty="0">
-              <a:solidFill>
-                <a:srgbClr val="000000"/>
-              </a:solidFill>
-              <a:latin typeface="Times New Roman"/>
-              <a:ea typeface="Times New Roman"/>
-              <a:cs typeface="Times New Roman"/>
-              <a:sym typeface="Times New Roman"/>
-            </a:endParaRPr>
-          </a:p>
-          <a:p>
-            <a:pPr algn="ctr">
-              <a:lnSpc>
-                <a:spcPts val="4200"/>
-              </a:lnSpc>
-              <a:spcBef>
-                <a:spcPct val="0"/>
-              </a:spcBef>
-            </a:pPr>
-            <a:r>
-              <a:rPr lang="en-US" sz="3000" dirty="0">
-                <a:solidFill>
-                  <a:srgbClr val="000000"/>
-                </a:solidFill>
-                <a:latin typeface="Times New Roman"/>
-                <a:ea typeface="Times New Roman"/>
-                <a:cs typeface="Times New Roman"/>
-                <a:sym typeface="Times New Roman"/>
-              </a:rPr>
-              <a:t>      4. </a:t>
-            </a:r>
-            <a:r>
-              <a:rPr lang="en-US" sz="3000" dirty="0" err="1">
-                <a:solidFill>
-                  <a:srgbClr val="000000"/>
-                </a:solidFill>
-                <a:latin typeface="Times New Roman"/>
-                <a:ea typeface="Times New Roman"/>
-                <a:cs typeface="Times New Roman"/>
-                <a:sym typeface="Times New Roman"/>
-              </a:rPr>
-              <a:t>Trần</a:t>
-            </a:r>
-            <a:r>
-              <a:rPr lang="en-US" sz="3000" dirty="0">
-                <a:solidFill>
-                  <a:srgbClr val="000000"/>
-                </a:solidFill>
-                <a:latin typeface="Times New Roman"/>
-                <a:ea typeface="Times New Roman"/>
-                <a:cs typeface="Times New Roman"/>
-                <a:sym typeface="Times New Roman"/>
-              </a:rPr>
-              <a:t> Hoàng Nam</a:t>
-            </a:r>
-          </a:p>
-          <a:p>
-            <a:pPr algn="ctr">
-              <a:lnSpc>
-                <a:spcPts val="4200"/>
-              </a:lnSpc>
-              <a:spcBef>
-                <a:spcPct val="0"/>
-              </a:spcBef>
-            </a:pPr>
-            <a:r>
-              <a:rPr lang="en-US" sz="3000" dirty="0">
-                <a:solidFill>
-                  <a:srgbClr val="000000"/>
-                </a:solidFill>
-                <a:latin typeface="Times New Roman"/>
-                <a:ea typeface="Times New Roman"/>
-                <a:cs typeface="Times New Roman"/>
-                <a:sym typeface="Times New Roman"/>
-              </a:rPr>
-              <a:t>    068206000088</a:t>
-            </a:r>
-          </a:p>
-          <a:p>
-            <a:pPr algn="ctr">
-              <a:lnSpc>
-                <a:spcPts val="4200"/>
-              </a:lnSpc>
-              <a:spcBef>
-                <a:spcPct val="0"/>
-              </a:spcBef>
-            </a:pPr>
-            <a:endParaRPr lang="en-US" sz="3000" dirty="0">
-              <a:solidFill>
-                <a:srgbClr val="000000"/>
-              </a:solidFill>
-              <a:latin typeface="Times New Roman"/>
-              <a:ea typeface="Times New Roman"/>
-              <a:cs typeface="Times New Roman"/>
-              <a:sym typeface="Times New Roman"/>
-            </a:endParaRPr>
-          </a:p>
-        </p:txBody>
-      </p:sp>
-      <p:sp>
-        <p:nvSpPr>
-          <p:cNvPr id="9" name="TextBox 6">
-            <a:extLst>
-              <a:ext uri="{FF2B5EF4-FFF2-40B4-BE49-F238E27FC236}">
-                <a16:creationId xmlns:a16="http://schemas.microsoft.com/office/drawing/2014/main" id="{BE68BD4F-A958-4C5A-AE89-68469B74C4CE}"/>
-              </a:ext>
-            </a:extLst>
-          </p:cNvPr>
-          <p:cNvSpPr txBox="1"/>
-          <p:nvPr/>
-        </p:nvSpPr>
-        <p:spPr>
-          <a:xfrm>
-            <a:off x="6669583" y="3238500"/>
-            <a:ext cx="4948833" cy="538609"/>
-          </a:xfrm>
-          <a:prstGeom prst="rect">
-            <a:avLst/>
-          </a:prstGeom>
-        </p:spPr>
-        <p:txBody>
-          <a:bodyPr lIns="0" tIns="0" rIns="0" bIns="0" rtlCol="0" anchor="t">
-            <a:spAutoFit/>
-          </a:bodyPr>
-          <a:lstStyle/>
-          <a:p>
-            <a:pPr algn="ctr">
-              <a:lnSpc>
-                <a:spcPts val="4200"/>
-              </a:lnSpc>
-              <a:spcBef>
-                <a:spcPct val="0"/>
-              </a:spcBef>
-            </a:pPr>
-            <a:r>
-              <a:rPr lang="en-US" sz="4000" b="1" dirty="0">
-                <a:solidFill>
-                  <a:srgbClr val="000000"/>
-                </a:solidFill>
-                <a:latin typeface="Times New Roman"/>
-                <a:ea typeface="Times New Roman"/>
-                <a:cs typeface="Times New Roman"/>
-                <a:sym typeface="Times New Roman"/>
-              </a:rPr>
-              <a:t>NHÓM 3</a:t>
-            </a:r>
-          </a:p>
-        </p:txBody>
-      </p:sp>
-    </p:spTree>
-  </p:cSld>
-  <p:clrMapOvr>
-    <a:masterClrMapping/>
-  </p:clrMapOvr>
-</p:sld>
-</file>
-
-<file path=ppt/slides/slide20.xml><?xml version="1.0" encoding="utf-8"?>
+<file path=ppt/slides/slide21.xml><?xml version="1.0" encoding="utf-8"?>
 <p:sld xmlns:a="http://schemas.openxmlformats.org/drawingml/2006/main" xmlns:r="http://schemas.openxmlformats.org/officeDocument/2006/relationships" xmlns:p="http://schemas.openxmlformats.org/presentationml/2006/main">
   <p:cSld>
     <p:spTree>
@@ -11350,7 +11647,7 @@
 </p:sld>
 </file>
 
-<file path=ppt/slides/slide21.xml><?xml version="1.0" encoding="utf-8"?>
+<file path=ppt/slides/slide22.xml><?xml version="1.0" encoding="utf-8"?>
 <p:sld xmlns:a="http://schemas.openxmlformats.org/drawingml/2006/main" xmlns:r="http://schemas.openxmlformats.org/officeDocument/2006/relationships" xmlns:p="http://schemas.openxmlformats.org/presentationml/2006/main">
   <p:cSld>
     <p:spTree>
@@ -12256,7 +12553,7 @@
 </p:sld>
 </file>
 
-<file path=ppt/slides/slide22.xml><?xml version="1.0" encoding="utf-8"?>
+<file path=ppt/slides/slide23.xml><?xml version="1.0" encoding="utf-8"?>
 <p:sld xmlns:a="http://schemas.openxmlformats.org/drawingml/2006/main" xmlns:r="http://schemas.openxmlformats.org/officeDocument/2006/relationships" xmlns:p="http://schemas.openxmlformats.org/presentationml/2006/main">
   <p:cSld>
     <p:spTree>
@@ -13505,7 +13802,7 @@
 </p:sld>
 </file>
 
-<file path=ppt/slides/slide23.xml><?xml version="1.0" encoding="utf-8"?>
+<file path=ppt/slides/slide24.xml><?xml version="1.0" encoding="utf-8"?>
 <p:sld xmlns:a="http://schemas.openxmlformats.org/drawingml/2006/main" xmlns:r="http://schemas.openxmlformats.org/officeDocument/2006/relationships" xmlns:p="http://schemas.openxmlformats.org/presentationml/2006/main">
   <p:cSld>
     <p:spTree>
@@ -14353,7 +14650,7 @@
 </p:sld>
 </file>
 
-<file path=ppt/slides/slide24.xml><?xml version="1.0" encoding="utf-8"?>
+<file path=ppt/slides/slide25.xml><?xml version="1.0" encoding="utf-8"?>
 <p:sld xmlns:a="http://schemas.openxmlformats.org/drawingml/2006/main" xmlns:r="http://schemas.openxmlformats.org/officeDocument/2006/relationships" xmlns:p="http://schemas.openxmlformats.org/presentationml/2006/main">
   <p:cSld>
     <p:spTree>

</xml_diff>